<commit_message>
0.1.0-beta.4: Showship logo, signature style, transparent default logo
</commit_message>
<xml_diff>
--- a/docs/example-deck.pptx
+++ b/docs/example-deck.pptx
@@ -2308,7 +2308,7 @@
       </p:sp>
       <p:pic>
         <p:nvPicPr>
-          <p:cNvPr id="4" name="Image 0" descr="/sessions/beautiful-vigilant-darwin/tmp/showship-deck-VBj71G/logo_trimmed.png">    </p:cNvPr>
+          <p:cNvPr id="4" name="Image 0" descr="/sessions/beautiful-vigilant-darwin/tmp/showship-deck-XigHks/logo_trimmed.png">    </p:cNvPr>
           <p:cNvPicPr>
             <a:picLocks noChangeAspect="1"/>
           </p:cNvPicPr>
@@ -2323,7 +2323,7 @@
         <p:spPr>
           <a:xfrm>
             <a:off x="640080" y="960120"/>
-            <a:ext cx="594360" cy="548640"/>
+            <a:ext cx="474699" cy="548640"/>
           </a:xfrm>
           <a:prstGeom prst="rect">
             <a:avLst/>
@@ -3994,7 +3994,7 @@
       </p:sp>
       <p:pic>
         <p:nvPicPr>
-          <p:cNvPr id="4" name="Image 0" descr="/sessions/beautiful-vigilant-darwin/tmp/showship-deck-VBj71G/logo_trimmed.png">    </p:cNvPr>
+          <p:cNvPr id="4" name="Image 0" descr="/sessions/beautiful-vigilant-darwin/tmp/showship-deck-XigHks/logo_trimmed.png">    </p:cNvPr>
           <p:cNvPicPr>
             <a:picLocks noChangeAspect="1"/>
           </p:cNvPicPr>
@@ -4009,7 +4009,7 @@
         <p:spPr>
           <a:xfrm>
             <a:off x="640080" y="960120"/>
-            <a:ext cx="594360" cy="548640"/>
+            <a:ext cx="474699" cy="548640"/>
           </a:xfrm>
           <a:prstGeom prst="rect">
             <a:avLst/>

</xml_diff>